<commit_message>
Simplificar credencial y resumen de seguridad en pitch v8
</commit_message>
<xml_diff>
--- a/docs/specs/006-validacion-pitch-entrega/materiales/pitch-v8-revision.pptx
+++ b/docs/specs/006-validacion-pitch-entrega/materiales/pitch-v8-revision.pptx
@@ -591,7 +591,7 @@
           </a:p>
           <a:p>
             <a:r>
-              <a:t>Escaneen el QR y entren con la cuenta del jurado. Amazon Cognito, el servicio de acceso de Amazon en la nube, valida su identidad. Ustedes pueden consultar como auditores, sin modificar la operación. La conexión va cifrada. Dejamos esta pantalla para sus preguntas.</a:t>
+              <a:t>Escaneen el QR y entren con este usuario y clave. El acceso usa AWS Cognito en la nube de Amazon, con conexión cifrada. Entran como auditores: pueden ver todo el sistema sin modificar datos. Dejamos la pantalla para sus preguntas.</a:t>
             </a:r>
           </a:p>
         </p:txBody>
@@ -5387,7 +5387,7 @@
         <p:spPr>
           <a:xfrm>
             <a:off x="5138928" y="1837943"/>
-            <a:ext cx="6135624" cy="210312"/>
+            <a:ext cx="1143000" cy="219456"/>
           </a:xfrm>
           <a:prstGeom prst="rect">
             <a:avLst/>
@@ -5412,7 +5412,7 @@
                 </a:solidFill>
                 <a:latin typeface="Open Sans"/>
               </a:rPr>
-              <a:t>USUARIO DEL JURADO</a:t>
+              <a:t>Usuario</a:t>
             </a:r>
           </a:p>
         </p:txBody>
@@ -5425,8 +5425,8 @@
         </p:nvSpPr>
         <p:spPr>
           <a:xfrm>
-            <a:off x="5138928" y="2093976"/>
-            <a:ext cx="6135624" cy="374904"/>
+            <a:off x="6355080" y="1792224"/>
+            <a:ext cx="4919472" cy="384048"/>
           </a:xfrm>
           <a:prstGeom prst="rect">
             <a:avLst/>
@@ -5451,7 +5451,7 @@
                 </a:solidFill>
                 <a:latin typeface="Open Sans"/>
               </a:rPr>
-              <a:t>jurado@istpetdev.doicela.dev</a:t>
+              <a:t>jurado@expo.ec</a:t>
             </a:r>
           </a:p>
         </p:txBody>
@@ -5464,7 +5464,7 @@
         </p:nvSpPr>
         <p:spPr>
           <a:xfrm>
-            <a:off x="5138928" y="2560320"/>
+            <a:off x="5138928" y="2331720"/>
             <a:ext cx="1143000" cy="219456"/>
           </a:xfrm>
           <a:prstGeom prst="rect">
@@ -5490,7 +5490,7 @@
                 </a:solidFill>
                 <a:latin typeface="Open Sans"/>
               </a:rPr>
-              <a:t>Contraseña</a:t>
+              <a:t>Clave</a:t>
             </a:r>
           </a:p>
         </p:txBody>
@@ -5503,7 +5503,7 @@
         </p:nvSpPr>
         <p:spPr>
           <a:xfrm>
-            <a:off x="6355080" y="2514600"/>
+            <a:off x="6355080" y="2286000"/>
             <a:ext cx="4919472" cy="384048"/>
           </a:xfrm>
           <a:prstGeom prst="rect">
@@ -5523,7 +5523,7 @@
               </a:spcAft>
             </a:pPr>
             <a:r>
-              <a:rPr sz="2200" b="1" i="0">
+              <a:rPr sz="2300" b="1" i="0">
                 <a:solidFill>
                   <a:srgbClr val="FFFFFF"/>
                 </a:solidFill>
@@ -5542,7 +5542,7 @@
         </p:nvSpPr>
         <p:spPr>
           <a:xfrm>
-            <a:off x="5138928" y="2926080"/>
+            <a:off x="5138928" y="2880360"/>
             <a:ext cx="6135624" cy="228600"/>
           </a:xfrm>
           <a:prstGeom prst="rect">
@@ -5568,7 +5568,7 @@
                 </a:solidFill>
                 <a:latin typeface="Open Sans"/>
               </a:rPr>
-              <a:t>Torre de Control → usar esta cuenta</a:t>
+              <a:t>Botón: Torre de Control · Rol Auditor (solo lectura)</a:t>
             </a:r>
           </a:p>
         </p:txBody>
@@ -5607,7 +5607,7 @@
                 </a:solidFill>
                 <a:latin typeface="Open Sans"/>
               </a:rPr>
-              <a:t>SEGURIDAD, EN PALABRAS SENCILLAS</a:t>
+              <a:t>SEGURIDAD · AWS COGNITO (NUBE)</a:t>
             </a:r>
           </a:p>
         </p:txBody>
@@ -5646,7 +5646,7 @@
                 </a:solidFill>
                 <a:latin typeface="Open Sans"/>
               </a:rPr>
-              <a:t>01  Amazon Cognito es el servicio de acceso de AWS.</a:t>
+              <a:t>01  AWS Cognito valida el ingreso en la nube de Amazon.</a:t>
             </a:r>
           </a:p>
         </p:txBody>
@@ -5685,7 +5685,7 @@
                 </a:solidFill>
                 <a:latin typeface="Open Sans"/>
               </a:rPr>
-              <a:t>02  AWS es la nube de Amazon: funciona por Internet.</a:t>
+              <a:t>02  Verifica usuario y clave antes de abrir el sistema.</a:t>
             </a:r>
           </a:p>
         </p:txBody>
@@ -5724,7 +5724,7 @@
                 </a:solidFill>
                 <a:latin typeface="Open Sans"/>
               </a:rPr>
-              <a:t>03  Cognito comprueba el usuario y la contraseña.</a:t>
+              <a:t>03  La clave la protege Cognito, no nuestra base.</a:t>
             </a:r>
           </a:p>
         </p:txBody>
@@ -5763,7 +5763,7 @@
                 </a:solidFill>
                 <a:latin typeface="Open Sans"/>
               </a:rPr>
-              <a:t>04  La contraseña la gestiona Cognito.</a:t>
+              <a:t>04  Al entrar entrega una sesión temporal.</a:t>
             </a:r>
           </a:p>
         </p:txBody>
@@ -5802,7 +5802,7 @@
                 </a:solidFill>
                 <a:latin typeface="Open Sans"/>
               </a:rPr>
-              <a:t>05  La aplicación recibe una sesión temporal.</a:t>
+              <a:t>05  La conexión viaja cifrada por HTTPS.</a:t>
             </a:r>
           </a:p>
         </p:txBody>
@@ -5841,7 +5841,7 @@
                 </a:solidFill>
                 <a:latin typeface="Open Sans"/>
               </a:rPr>
-              <a:t>06  Cada cuenta tiene permisos según su función.</a:t>
+              <a:t>06  Cada cuenta tiene permisos según su rol.</a:t>
             </a:r>
           </a:p>
         </p:txBody>
@@ -5880,7 +5880,7 @@
                 </a:solidFill>
                 <a:latin typeface="Open Sans"/>
               </a:rPr>
-              <a:t>07  El jurado entra con el rol Auditor.</a:t>
+              <a:t>07  El jurado entra con rol Auditor.</a:t>
             </a:r>
           </a:p>
         </p:txBody>
@@ -5919,7 +5919,7 @@
                 </a:solidFill>
                 <a:latin typeface="Open Sans"/>
               </a:rPr>
-              <a:t>08  Puede consultar; no modificar la operación.</a:t>
+              <a:t>08  Modo solo lectura: ver todo sin alterar datos.</a:t>
             </a:r>
           </a:p>
         </p:txBody>
@@ -5958,7 +5958,7 @@
                 </a:solidFill>
                 <a:latin typeface="Open Sans"/>
               </a:rPr>
-              <a:t>09  La conexión usa HTTPS para cifrar los datos.</a:t>
+              <a:t>09  El servidor bloquea cualquier intento de edición.</a:t>
             </a:r>
           </a:p>
         </p:txBody>
@@ -5997,7 +5997,7 @@
                 </a:solidFill>
                 <a:latin typeface="Open Sans"/>
               </a:rPr>
-              <a:t>10  La cuenta puede desactivarse al terminar.</a:t>
+              <a:t>10  La cuenta se desactiva al cerrar la evaluación.</a:t>
             </a:r>
           </a:p>
         </p:txBody>

</xml_diff>